<commit_message>
docs(readme): add team clone & setup guide, update requirements.txt with onnxruntime
</commit_message>
<xml_diff>
--- a/SIH2026_Criminal_Network_Analysis_System_6Pages.pptx
+++ b/SIH2026_Criminal_Network_Analysis_System_6Pages.pptx
@@ -5,15 +5,15 @@
     <p:sldMasterId id="2147483648" r:id="rId1"/>
   </p:sldMasterIdLst>
   <p:notesMasterIdLst>
-    <p:notesMasterId r:id="rId9"/>
+    <p:notesMasterId r:id="rId8"/>
   </p:notesMasterIdLst>
   <p:sldIdLst>
-    <p:sldId id="256" r:id="rId7"/>
-    <p:sldId id="257" r:id="rId8"/>
-    <p:sldId id="258" r:id="rId6"/>
-    <p:sldId id="262" r:id="rId2"/>
-    <p:sldId id="263" r:id="rId14"/>
-    <p:sldId id="264" r:id="rId15"/>
+    <p:sldId id="256" r:id="rId2"/>
+    <p:sldId id="257" r:id="rId3"/>
+    <p:sldId id="258" r:id="rId4"/>
+    <p:sldId id="262" r:id="rId5"/>
+    <p:sldId id="263" r:id="rId6"/>
+    <p:sldId id="264" r:id="rId7"/>
   </p:sldIdLst>
   <p:sldSz cx="12192000" cy="6858000"/>
   <p:notesSz cx="6858000" cy="9144000"/>
@@ -161,6 +161,43 @@
 </p:presentation>
 </file>
 
+<file path=ppt/changesInfos/changesInfo1.xml><?xml version="1.0" encoding="utf-8"?>
+<pc:chgInfo xmlns:a="http://schemas.openxmlformats.org/drawingml/2006/main" xmlns:r="http://schemas.openxmlformats.org/officeDocument/2006/relationships" xmlns:ac="http://schemas.microsoft.com/office/drawing/2013/main/command" xmlns:pc="http://schemas.microsoft.com/office/powerpoint/2013/main/command">
+  <pc:docChgLst>
+    <pc:chgData name="vishnukant sharma" userId="b0978f70c0b7e60c" providerId="LiveId" clId="{D5AC3541-C01C-4FA2-A26F-5A68DA25AB6E}"/>
+    <pc:docChg chg="modSld">
+      <pc:chgData name="vishnukant sharma" userId="b0978f70c0b7e60c" providerId="LiveId" clId="{D5AC3541-C01C-4FA2-A26F-5A68DA25AB6E}" dt="2026-09-07T09:54:46.735" v="4" actId="1076"/>
+      <pc:docMkLst>
+        <pc:docMk/>
+      </pc:docMkLst>
+      <pc:sldChg chg="modSp mod">
+        <pc:chgData name="vishnukant sharma" userId="b0978f70c0b7e60c" providerId="LiveId" clId="{D5AC3541-C01C-4FA2-A26F-5A68DA25AB6E}" dt="2026-09-07T09:54:46.735" v="4" actId="1076"/>
+        <pc:sldMkLst>
+          <pc:docMk/>
+          <pc:sldMk cId="0" sldId="264"/>
+        </pc:sldMkLst>
+        <pc:spChg chg="mod">
+          <ac:chgData name="vishnukant sharma" userId="b0978f70c0b7e60c" providerId="LiveId" clId="{D5AC3541-C01C-4FA2-A26F-5A68DA25AB6E}" dt="2026-09-07T09:54:46.735" v="4" actId="1076"/>
+          <ac:spMkLst>
+            <pc:docMk/>
+            <pc:sldMk cId="0" sldId="264"/>
+            <ac:spMk id="3" creationId="{00000000-0000-0000-0000-000000000000}"/>
+          </ac:spMkLst>
+        </pc:spChg>
+        <pc:spChg chg="mod">
+          <ac:chgData name="vishnukant sharma" userId="b0978f70c0b7e60c" providerId="LiveId" clId="{D5AC3541-C01C-4FA2-A26F-5A68DA25AB6E}" dt="2026-09-07T09:53:58.518" v="3" actId="20577"/>
+          <ac:spMkLst>
+            <pc:docMk/>
+            <pc:sldMk cId="0" sldId="264"/>
+            <ac:spMk id="8" creationId="{00000000-0000-0000-0000-000000000000}"/>
+          </ac:spMkLst>
+        </pc:spChg>
+      </pc:sldChg>
+    </pc:docChg>
+  </pc:docChgLst>
+</pc:chgInfo>
+</file>
+
 <file path=ppt/notesMasters/notesMaster1.xml><?xml version="1.0" encoding="utf-8"?>
 <p:notesMaster xmlns:a="http://schemas.openxmlformats.org/drawingml/2006/main" xmlns:r="http://schemas.openxmlformats.org/officeDocument/2006/relationships" xmlns:p="http://schemas.openxmlformats.org/presentationml/2006/main">
   <p:cSld>
@@ -261,7 +298,7 @@
             <a:fld id="{C4D5ADD5-2BBC-4A94-8F86-D9013941F742}" type="datetimeFigureOut">
               <a:rPr lang="en-US"/>
               <a:pPr/>
-              <a:t>6/26/2025</a:t>
+              <a:t>9/7/2026</a:t>
             </a:fld>
             <a:endParaRPr lang="en-US"/>
           </a:p>
@@ -762,7 +799,7 @@
           <a:p>
             <a:fld id="{E60792E3-D524-454C-8AFD-A91972900BCB}" type="datetime1">
               <a:rPr lang="en-US" smtClean="0"/>
-              <a:t>6/26/2025</a:t>
+              <a:t>9/7/2026</a:t>
             </a:fld>
             <a:endParaRPr lang="en-US"/>
           </a:p>
@@ -944,7 +981,7 @@
           <a:p>
             <a:fld id="{053C3A68-6922-42D3-8905-ECC2D82A3469}" type="datetime1">
               <a:rPr lang="en-US" smtClean="0"/>
-              <a:t>6/26/2025</a:t>
+              <a:t>9/7/2026</a:t>
             </a:fld>
             <a:endParaRPr lang="en-US"/>
           </a:p>
@@ -1136,7 +1173,7 @@
           <a:p>
             <a:fld id="{CB69E9F4-7604-4950-A8B2-8ACDEDB1506E}" type="datetime1">
               <a:rPr lang="en-US" smtClean="0"/>
-              <a:t>6/26/2025</a:t>
+              <a:t>9/7/2026</a:t>
             </a:fld>
             <a:endParaRPr lang="en-US"/>
           </a:p>
@@ -1318,7 +1355,7 @@
           <a:p>
             <a:fld id="{708B7524-32A2-4C20-A58C-BC3BAA1042FC}" type="datetime1">
               <a:rPr lang="en-US" smtClean="0"/>
-              <a:t>6/26/2025</a:t>
+              <a:t>9/7/2026</a:t>
             </a:fld>
             <a:endParaRPr lang="en-US"/>
           </a:p>
@@ -1577,7 +1614,7 @@
           <a:p>
             <a:fld id="{1E994447-D6B2-43BB-A877-57F1A267B999}" type="datetime1">
               <a:rPr lang="en-US" smtClean="0"/>
-              <a:t>6/26/2025</a:t>
+              <a:t>9/7/2026</a:t>
             </a:fld>
             <a:endParaRPr lang="en-US"/>
           </a:p>
@@ -1876,7 +1913,7 @@
           <a:p>
             <a:fld id="{68920E16-BD35-483C-AA6B-346FC7E46DEA}" type="datetime1">
               <a:rPr lang="en-US" smtClean="0"/>
-              <a:t>6/26/2025</a:t>
+              <a:t>9/7/2026</a:t>
             </a:fld>
             <a:endParaRPr lang="en-US"/>
           </a:p>
@@ -2309,7 +2346,7 @@
           <a:p>
             <a:fld id="{2FEAC6F8-5103-4FC0-A69E-5C6AE6469DA8}" type="datetime1">
               <a:rPr lang="en-US" smtClean="0"/>
-              <a:t>6/26/2025</a:t>
+              <a:t>9/7/2026</a:t>
             </a:fld>
             <a:endParaRPr lang="en-US"/>
           </a:p>
@@ -2440,7 +2477,7 @@
           <a:p>
             <a:fld id="{C60C6921-0627-4C8F-83D5-0CF936D2FFDD}" type="datetime1">
               <a:rPr lang="en-US" smtClean="0"/>
-              <a:t>6/26/2025</a:t>
+              <a:t>9/7/2026</a:t>
             </a:fld>
             <a:endParaRPr lang="en-US"/>
           </a:p>
@@ -2549,7 +2586,7 @@
           <a:p>
             <a:fld id="{2FF08AD7-8103-40F8-983C-E2BA6BB9CBE0}" type="datetime1">
               <a:rPr lang="en-US" smtClean="0"/>
-              <a:t>6/26/2025</a:t>
+              <a:t>9/7/2026</a:t>
             </a:fld>
             <a:endParaRPr lang="en-US"/>
           </a:p>
@@ -2838,7 +2875,7 @@
           <a:p>
             <a:fld id="{DF8C06B4-9380-4A4D-AF49-A3596E17DAF5}" type="datetime1">
               <a:rPr lang="en-US" smtClean="0"/>
-              <a:t>6/26/2025</a:t>
+              <a:t>9/7/2026</a:t>
             </a:fld>
             <a:endParaRPr lang="en-US"/>
           </a:p>
@@ -3107,7 +3144,7 @@
           <a:p>
             <a:fld id="{EF7FDEF1-C582-4E22-9E77-D68326471F28}" type="datetime1">
               <a:rPr lang="en-US" smtClean="0"/>
-              <a:t>6/26/2025</a:t>
+              <a:t>9/7/2026</a:t>
             </a:fld>
             <a:endParaRPr lang="en-US"/>
           </a:p>
@@ -3350,7 +3387,7 @@
           <a:p>
             <a:fld id="{780A9602-A9A9-453F-AEF1-37B5837E02CD}" type="datetime1">
               <a:rPr lang="en-US" smtClean="0"/>
-              <a:t>6/26/2025</a:t>
+              <a:t>9/7/2026</a:t>
             </a:fld>
             <a:endParaRPr lang="en-US"/>
           </a:p>
@@ -3869,7 +3906,7 @@
 </file>
 
 <file path=ppt/slides/slide1.xml><?xml version="1.0" encoding="utf-8"?>
-<p:sld xmlns:a="http://schemas.openxmlformats.org/drawingml/2006/main" xmlns:p="http://schemas.openxmlformats.org/presentationml/2006/main" xmlns:r="http://schemas.openxmlformats.org/officeDocument/2006/relationships">
+<p:sld xmlns:a="http://schemas.openxmlformats.org/drawingml/2006/main" xmlns:r="http://schemas.openxmlformats.org/officeDocument/2006/relationships" xmlns:p="http://schemas.openxmlformats.org/presentationml/2006/main">
   <p:cSld>
     <p:spTree>
       <p:nvGrpSpPr>
@@ -3877,7 +3914,14 @@
         <p:cNvGrpSpPr/>
         <p:nvPr/>
       </p:nvGrpSpPr>
-      <p:grpSpPr/>
+      <p:grpSpPr>
+        <a:xfrm>
+          <a:off x="0" y="0"/>
+          <a:ext cx="0" cy="0"/>
+          <a:chOff x="0" y="0"/>
+          <a:chExt cx="0" cy="0"/>
+        </a:xfrm>
+      </p:grpSpPr>
       <p:sp>
         <p:nvSpPr>
           <p:cNvPr id="2" name="Hexagon 1"/>
@@ -3922,6 +3966,7 @@
                 <a:latin typeface="Segoe UI"/>
               </a:defRPr>
             </a:pPr>
+            <a:endParaRPr/>
           </a:p>
         </p:txBody>
       </p:sp>
@@ -4079,28 +4124,19 @@
               </a:defRPr>
             </a:pPr>
             <a:r>
-              <a:rPr b="1" sz="1800">
+              <a:rPr sz="1800" b="1">
                 <a:latin typeface="Calibri"/>
               </a:rPr>
               <a:t>• </a:t>
             </a:r>
             <a:r>
-              <a:rPr b="1" sz="1750">
+              <a:rPr sz="1750" b="1">
                 <a:solidFill>
                   <a:srgbClr val="000000"/>
                 </a:solidFill>
                 <a:latin typeface="Calibri"/>
               </a:rPr>
-              <a:t>Problem Statement ID – </a:t>
-            </a:r>
-            <a:r>
-              <a:rPr b="1" sz="1750">
-                <a:solidFill>
-                  <a:srgbClr val="000000"/>
-                </a:solidFill>
-                <a:latin typeface="Calibri"/>
-              </a:rPr>
-              <a:t>26189</a:t>
+              <a:t>Problem Statement ID – 26189</a:t>
             </a:r>
           </a:p>
           <a:p>
@@ -4116,13 +4152,13 @@
               </a:defRPr>
             </a:pPr>
             <a:r>
-              <a:rPr b="1" sz="1800">
+              <a:rPr sz="1800" b="1">
                 <a:latin typeface="Calibri"/>
               </a:rPr>
               <a:t>• </a:t>
             </a:r>
             <a:r>
-              <a:rPr b="1" sz="1750">
+              <a:rPr sz="1750" b="1">
                 <a:solidFill>
                   <a:srgbClr val="000000"/>
                 </a:solidFill>
@@ -4131,7 +4167,7 @@
               <a:t>Problem Statement Title - </a:t>
             </a:r>
             <a:r>
-              <a:rPr b="0" sz="1750">
+              <a:rPr sz="1750" b="0">
                 <a:solidFill>
                   <a:srgbClr val="000000"/>
                 </a:solidFill>
@@ -4153,28 +4189,19 @@
               </a:defRPr>
             </a:pPr>
             <a:r>
-              <a:rPr b="1" sz="1800">
+              <a:rPr sz="1800" b="1">
                 <a:latin typeface="Calibri"/>
               </a:rPr>
               <a:t>• </a:t>
             </a:r>
             <a:r>
-              <a:rPr b="1" sz="1750">
+              <a:rPr sz="1750" b="1">
                 <a:solidFill>
                   <a:srgbClr val="000000"/>
                 </a:solidFill>
                 <a:latin typeface="Calibri"/>
               </a:rPr>
-              <a:t>Theme - </a:t>
-            </a:r>
-            <a:r>
-              <a:rPr b="1" sz="1750">
-                <a:solidFill>
-                  <a:srgbClr val="000000"/>
-                </a:solidFill>
-                <a:latin typeface="Calibri"/>
-              </a:rPr>
-              <a:t>Blockchain &amp; Cybersecurity</a:t>
+              <a:t>Theme - Blockchain &amp; Cybersecurity</a:t>
             </a:r>
           </a:p>
           <a:p>
@@ -4190,28 +4217,19 @@
               </a:defRPr>
             </a:pPr>
             <a:r>
-              <a:rPr b="1" sz="1800">
+              <a:rPr sz="1800" b="1">
                 <a:latin typeface="Calibri"/>
               </a:rPr>
               <a:t>• </a:t>
             </a:r>
             <a:r>
-              <a:rPr b="1" sz="1750">
+              <a:rPr sz="1750" b="1">
                 <a:solidFill>
                   <a:srgbClr val="000000"/>
                 </a:solidFill>
                 <a:latin typeface="Calibri"/>
               </a:rPr>
-              <a:t>PS Category - </a:t>
-            </a:r>
-            <a:r>
-              <a:rPr b="1" sz="1750">
-                <a:solidFill>
-                  <a:srgbClr val="000000"/>
-                </a:solidFill>
-                <a:latin typeface="Calibri"/>
-              </a:rPr>
-              <a:t>Software</a:t>
+              <a:t>PS Category - Software</a:t>
             </a:r>
           </a:p>
           <a:p>
@@ -4227,28 +4245,19 @@
               </a:defRPr>
             </a:pPr>
             <a:r>
-              <a:rPr b="1" sz="1800">
+              <a:rPr sz="1800" b="1">
                 <a:latin typeface="Calibri"/>
               </a:rPr>
               <a:t>• </a:t>
             </a:r>
             <a:r>
-              <a:rPr b="1" sz="1750">
+              <a:rPr sz="1750" b="1">
                 <a:solidFill>
                   <a:srgbClr val="000000"/>
                 </a:solidFill>
                 <a:latin typeface="Calibri"/>
               </a:rPr>
-              <a:t>Team ID - </a:t>
-            </a:r>
-            <a:r>
-              <a:rPr b="1" sz="1750">
-                <a:solidFill>
-                  <a:srgbClr val="000000"/>
-                </a:solidFill>
-                <a:latin typeface="Calibri"/>
-              </a:rPr>
-              <a:t>SIH2026-ST-842</a:t>
+              <a:t>Team ID - SIH2026-ST-842</a:t>
             </a:r>
           </a:p>
           <a:p>
@@ -4264,28 +4273,19 @@
               </a:defRPr>
             </a:pPr>
             <a:r>
-              <a:rPr b="1" sz="1800">
+              <a:rPr sz="1800" b="1">
                 <a:latin typeface="Calibri"/>
               </a:rPr>
               <a:t>• </a:t>
             </a:r>
             <a:r>
-              <a:rPr b="1" sz="1750">
+              <a:rPr sz="1750" b="1">
                 <a:solidFill>
                   <a:srgbClr val="000000"/>
                 </a:solidFill>
                 <a:latin typeface="Calibri"/>
               </a:rPr>
-              <a:t>Team Name (Registered on portal) – </a:t>
-            </a:r>
-            <a:r>
-              <a:rPr b="1" sz="1750">
-                <a:solidFill>
-                  <a:srgbClr val="000000"/>
-                </a:solidFill>
-                <a:latin typeface="Calibri"/>
-              </a:rPr>
-              <a:t>Stryker</a:t>
+              <a:t>Team Name (Registered on portal) – Stryker</a:t>
             </a:r>
           </a:p>
         </p:txBody>
@@ -4299,7 +4299,7 @@
 </file>
 
 <file path=ppt/slides/slide2.xml><?xml version="1.0" encoding="utf-8"?>
-<p:sld xmlns:a="http://schemas.openxmlformats.org/drawingml/2006/main" xmlns:p="http://schemas.openxmlformats.org/presentationml/2006/main" xmlns:r="http://schemas.openxmlformats.org/officeDocument/2006/relationships">
+<p:sld xmlns:a="http://schemas.openxmlformats.org/drawingml/2006/main" xmlns:r="http://schemas.openxmlformats.org/officeDocument/2006/relationships" xmlns:p="http://schemas.openxmlformats.org/presentationml/2006/main">
   <p:cSld>
     <p:spTree>
       <p:nvGrpSpPr>
@@ -4307,7 +4307,14 @@
         <p:cNvGrpSpPr/>
         <p:nvPr/>
       </p:nvGrpSpPr>
-      <p:grpSpPr/>
+      <p:grpSpPr>
+        <a:xfrm>
+          <a:off x="0" y="0"/>
+          <a:ext cx="0" cy="0"/>
+          <a:chOff x="0" y="0"/>
+          <a:chExt cx="0" cy="0"/>
+        </a:xfrm>
+      </p:grpSpPr>
       <p:sp>
         <p:nvSpPr>
           <p:cNvPr id="2" name="Oval 1"/>
@@ -4346,7 +4353,7 @@
           </a:fontRef>
         </p:style>
         <p:txBody>
-          <a:bodyPr rtlCol="0" anchor="ctr" wrap="square"/>
+          <a:bodyPr wrap="square" rtlCol="0" anchor="ctr"/>
           <a:lstStyle/>
           <a:p>
             <a:pPr algn="ctr">
@@ -4463,6 +4470,7 @@
           <a:lstStyle/>
           <a:p>
             <a:pPr algn="ctr"/>
+            <a:endParaRPr/>
           </a:p>
         </p:txBody>
       </p:sp>
@@ -4580,6 +4588,7 @@
           <a:lstStyle/>
           <a:p>
             <a:pPr algn="ctr"/>
+            <a:endParaRPr/>
           </a:p>
         </p:txBody>
       </p:sp>
@@ -4830,6 +4839,7 @@
           <a:lstStyle/>
           <a:p>
             <a:pPr algn="ctr"/>
+            <a:endParaRPr/>
           </a:p>
         </p:txBody>
       </p:sp>
@@ -5009,7 +5019,7 @@
 </file>
 
 <file path=ppt/slides/slide3.xml><?xml version="1.0" encoding="utf-8"?>
-<p:sld xmlns:a="http://schemas.openxmlformats.org/drawingml/2006/main" xmlns:p="http://schemas.openxmlformats.org/presentationml/2006/main" xmlns:r="http://schemas.openxmlformats.org/officeDocument/2006/relationships">
+<p:sld xmlns:a="http://schemas.openxmlformats.org/drawingml/2006/main" xmlns:r="http://schemas.openxmlformats.org/officeDocument/2006/relationships" xmlns:p="http://schemas.openxmlformats.org/presentationml/2006/main">
   <p:cSld>
     <p:spTree>
       <p:nvGrpSpPr>
@@ -5017,7 +5027,14 @@
         <p:cNvGrpSpPr/>
         <p:nvPr/>
       </p:nvGrpSpPr>
-      <p:grpSpPr/>
+      <p:grpSpPr>
+        <a:xfrm>
+          <a:off x="0" y="0"/>
+          <a:ext cx="0" cy="0"/>
+          <a:chOff x="0" y="0"/>
+          <a:chExt cx="0" cy="0"/>
+        </a:xfrm>
+      </p:grpSpPr>
       <p:sp>
         <p:nvSpPr>
           <p:cNvPr id="2" name="Oval 1"/>
@@ -5056,7 +5073,7 @@
           </a:fontRef>
         </p:style>
         <p:txBody>
-          <a:bodyPr rtlCol="0" anchor="ctr" wrap="square"/>
+          <a:bodyPr wrap="square" rtlCol="0" anchor="ctr"/>
           <a:lstStyle/>
           <a:p>
             <a:pPr algn="ctr">
@@ -5173,6 +5190,7 @@
           <a:lstStyle/>
           <a:p>
             <a:pPr algn="ctr"/>
+            <a:endParaRPr/>
           </a:p>
         </p:txBody>
       </p:sp>
@@ -5280,8 +5298,8 @@
 </p:sld>
 </file>
 
-<file path=ppt/slides/slide7.xml><?xml version="1.0" encoding="utf-8"?>
-<p:sld xmlns:a="http://schemas.openxmlformats.org/drawingml/2006/main" xmlns:p="http://schemas.openxmlformats.org/presentationml/2006/main" xmlns:r="http://schemas.openxmlformats.org/officeDocument/2006/relationships">
+<file path=ppt/slides/slide4.xml><?xml version="1.0" encoding="utf-8"?>
+<p:sld xmlns:a="http://schemas.openxmlformats.org/drawingml/2006/main" xmlns:r="http://schemas.openxmlformats.org/officeDocument/2006/relationships" xmlns:p="http://schemas.openxmlformats.org/presentationml/2006/main">
   <p:cSld>
     <p:spTree>
       <p:nvGrpSpPr>
@@ -5289,7 +5307,14 @@
         <p:cNvGrpSpPr/>
         <p:nvPr/>
       </p:nvGrpSpPr>
-      <p:grpSpPr/>
+      <p:grpSpPr>
+        <a:xfrm>
+          <a:off x="0" y="0"/>
+          <a:ext cx="0" cy="0"/>
+          <a:chOff x="0" y="0"/>
+          <a:chExt cx="0" cy="0"/>
+        </a:xfrm>
+      </p:grpSpPr>
       <p:sp>
         <p:nvSpPr>
           <p:cNvPr id="2" name="Oval 1"/>
@@ -5328,7 +5353,7 @@
           </a:fontRef>
         </p:style>
         <p:txBody>
-          <a:bodyPr rtlCol="0" anchor="ctr" wrap="square"/>
+          <a:bodyPr wrap="square" rtlCol="0" anchor="ctr"/>
           <a:lstStyle/>
           <a:p>
             <a:pPr algn="ctr">
@@ -5445,6 +5470,7 @@
           <a:lstStyle/>
           <a:p>
             <a:pPr algn="ctr"/>
+            <a:endParaRPr/>
           </a:p>
         </p:txBody>
       </p:sp>
@@ -5562,6 +5588,7 @@
           <a:lstStyle/>
           <a:p>
             <a:pPr algn="ctr"/>
+            <a:endParaRPr/>
           </a:p>
         </p:txBody>
       </p:sp>
@@ -5746,6 +5773,7 @@
           <a:lstStyle/>
           <a:p>
             <a:pPr algn="ctr"/>
+            <a:endParaRPr/>
           </a:p>
         </p:txBody>
       </p:sp>
@@ -5905,6 +5933,7 @@
           <a:lstStyle/>
           <a:p>
             <a:pPr algn="ctr"/>
+            <a:endParaRPr/>
           </a:p>
         </p:txBody>
       </p:sp>
@@ -6005,8 +6034,8 @@
 </p:sld>
 </file>
 
-<file path=ppt/slides/slide8.xml><?xml version="1.0" encoding="utf-8"?>
-<p:sld xmlns:a="http://schemas.openxmlformats.org/drawingml/2006/main" xmlns:p="http://schemas.openxmlformats.org/presentationml/2006/main" xmlns:r="http://schemas.openxmlformats.org/officeDocument/2006/relationships">
+<file path=ppt/slides/slide5.xml><?xml version="1.0" encoding="utf-8"?>
+<p:sld xmlns:a="http://schemas.openxmlformats.org/drawingml/2006/main" xmlns:r="http://schemas.openxmlformats.org/officeDocument/2006/relationships" xmlns:p="http://schemas.openxmlformats.org/presentationml/2006/main">
   <p:cSld>
     <p:spTree>
       <p:nvGrpSpPr>
@@ -6014,7 +6043,14 @@
         <p:cNvGrpSpPr/>
         <p:nvPr/>
       </p:nvGrpSpPr>
-      <p:grpSpPr/>
+      <p:grpSpPr>
+        <a:xfrm>
+          <a:off x="0" y="0"/>
+          <a:ext cx="0" cy="0"/>
+          <a:chOff x="0" y="0"/>
+          <a:chExt cx="0" cy="0"/>
+        </a:xfrm>
+      </p:grpSpPr>
       <p:sp>
         <p:nvSpPr>
           <p:cNvPr id="2" name="Oval 1"/>
@@ -6053,7 +6089,7 @@
           </a:fontRef>
         </p:style>
         <p:txBody>
-          <a:bodyPr rtlCol="0" anchor="ctr" wrap="square"/>
+          <a:bodyPr wrap="square" rtlCol="0" anchor="ctr"/>
           <a:lstStyle/>
           <a:p>
             <a:pPr algn="ctr">
@@ -6170,6 +6206,7 @@
           <a:lstStyle/>
           <a:p>
             <a:pPr algn="ctr"/>
+            <a:endParaRPr/>
           </a:p>
         </p:txBody>
       </p:sp>
@@ -6287,6 +6324,7 @@
           <a:lstStyle/>
           <a:p>
             <a:pPr algn="ctr"/>
+            <a:endParaRPr/>
           </a:p>
         </p:txBody>
       </p:sp>
@@ -6597,6 +6635,7 @@
           <a:lstStyle/>
           <a:p>
             <a:pPr algn="ctr"/>
+            <a:endParaRPr/>
           </a:p>
         </p:txBody>
       </p:sp>
@@ -6738,8 +6777,8 @@
 </p:sld>
 </file>
 
-<file path=ppt/slides/slide9.xml><?xml version="1.0" encoding="utf-8"?>
-<p:sld xmlns:a="http://schemas.openxmlformats.org/drawingml/2006/main" xmlns:p="http://schemas.openxmlformats.org/presentationml/2006/main" xmlns:r="http://schemas.openxmlformats.org/officeDocument/2006/relationships">
+<file path=ppt/slides/slide6.xml><?xml version="1.0" encoding="utf-8"?>
+<p:sld xmlns:a="http://schemas.openxmlformats.org/drawingml/2006/main" xmlns:r="http://schemas.openxmlformats.org/officeDocument/2006/relationships" xmlns:p="http://schemas.openxmlformats.org/presentationml/2006/main">
   <p:cSld>
     <p:spTree>
       <p:nvGrpSpPr>
@@ -6747,7 +6786,14 @@
         <p:cNvGrpSpPr/>
         <p:nvPr/>
       </p:nvGrpSpPr>
-      <p:grpSpPr/>
+      <p:grpSpPr>
+        <a:xfrm>
+          <a:off x="0" y="0"/>
+          <a:ext cx="0" cy="0"/>
+          <a:chOff x="0" y="0"/>
+          <a:chExt cx="0" cy="0"/>
+        </a:xfrm>
+      </p:grpSpPr>
       <p:sp>
         <p:nvSpPr>
           <p:cNvPr id="2" name="Oval 1"/>
@@ -6786,7 +6832,7 @@
           </a:fontRef>
         </p:style>
         <p:txBody>
-          <a:bodyPr rtlCol="0" anchor="ctr" wrap="square"/>
+          <a:bodyPr wrap="square" rtlCol="0" anchor="ctr"/>
           <a:lstStyle/>
           <a:p>
             <a:pPr algn="ctr">
@@ -6811,7 +6857,7 @@
         </p:nvSpPr>
         <p:spPr>
           <a:xfrm>
-            <a:off x="1905000" y="101600"/>
+            <a:off x="1582420" y="101600"/>
             <a:ext cx="8381999" cy="825500"/>
           </a:xfrm>
           <a:prstGeom prst="rect">
@@ -6834,6 +6880,7 @@
               </a:defRPr>
             </a:pPr>
             <a:r>
+              <a:rPr dirty="0"/>
               <a:t>RESEARCH, REFERENCES &amp; CONCLUSION</a:t>
             </a:r>
           </a:p>
@@ -6903,6 +6950,7 @@
           <a:lstStyle/>
           <a:p>
             <a:pPr algn="ctr"/>
+            <a:endParaRPr/>
           </a:p>
         </p:txBody>
       </p:sp>
@@ -6986,8 +7034,8 @@
         </p:nvSpPr>
         <p:spPr>
           <a:xfrm>
-            <a:off x="1270000" y="1905000"/>
-            <a:ext cx="9652000" cy="3175000"/>
+            <a:off x="1270000" y="1849743"/>
+            <a:ext cx="9652000" cy="3285515"/>
           </a:xfrm>
           <a:prstGeom prst="rect">
             <a:avLst/>
@@ -7012,6 +7060,7 @@
               </a:defRPr>
             </a:pPr>
             <a:r>
+              <a:rPr dirty="0"/>
               <a:t>Academic, Legal &amp; Operational Frameworks</a:t>
             </a:r>
           </a:p>
@@ -7028,6 +7077,7 @@
               </a:defRPr>
             </a:pPr>
             <a:r>
+              <a:rPr dirty="0"/>
               <a:t>1. Network Science &amp; Covert Syndicate Analysis :</a:t>
             </a:r>
           </a:p>
@@ -7044,6 +7094,7 @@
               </a:defRPr>
             </a:pPr>
             <a:r>
+              <a:rPr dirty="0"/>
               <a:t>Betweenness Centrality (Freeman, 1977) &amp; PageRank algorithms optimized for identifying high-influence brokers and shadow leaders in criminal networks.</a:t>
             </a:r>
           </a:p>
@@ -7060,6 +7111,7 @@
               </a:defRPr>
             </a:pPr>
             <a:r>
+              <a:rPr dirty="0"/>
               <a:t>2. Multi-Agent Autonomous Intelligence :</a:t>
             </a:r>
           </a:p>
@@ -7076,6 +7128,7 @@
               </a:defRPr>
             </a:pPr>
             <a:r>
+              <a:rPr dirty="0"/>
               <a:t>Agency Swarm orchestration architecture dividing investigative labor among specialized autonomous agents (Data Intel, Network Analysis, Threat Scoring, Forensic Reporting).</a:t>
             </a:r>
           </a:p>
@@ -7092,6 +7145,7 @@
               </a:defRPr>
             </a:pPr>
             <a:r>
+              <a:rPr dirty="0"/>
               <a:t>3. Indian Statutory Forensic Standards :</a:t>
             </a:r>
           </a:p>
@@ -7108,7 +7162,24 @@
               </a:defRPr>
             </a:pPr>
             <a:r>
-              <a:t>Section 63 of Bharatiya Sakshya Adhiniyam (BSA, 2023) / Section 65B Indian Evidence Act compliant digital hash chains ensuring tamper-evident chain of custody.</a:t>
+              <a:rPr dirty="0"/>
+              <a:t>Section 63 of Bharatiya </a:t>
+            </a:r>
+            <a:r>
+              <a:rPr dirty="0" err="1"/>
+              <a:t>Sakshya</a:t>
+            </a:r>
+            <a:r>
+              <a:rPr lang="en-US" dirty="0"/>
+              <a:t> </a:t>
+            </a:r>
+            <a:r>
+              <a:rPr dirty="0" err="1"/>
+              <a:t>Adhiniyam</a:t>
+            </a:r>
+            <a:r>
+              <a:rPr dirty="0"/>
+              <a:t> (BSA, 2023) / Section 65B Indian Evidence Act compliant digital hash chains ensuring tamper-evident chain of custody.</a:t>
             </a:r>
           </a:p>
           <a:p>
@@ -7124,6 +7195,7 @@
               </a:defRPr>
             </a:pPr>
             <a:r>
+              <a:rPr dirty="0"/>
               <a:t>4. Financial Crime &amp; Hawala Detection :</a:t>
             </a:r>
           </a:p>
@@ -7140,6 +7212,7 @@
               </a:defRPr>
             </a:pPr>
             <a:r>
+              <a:rPr dirty="0"/>
               <a:t>Financial Action Task Force (FATF) and Reserve Bank of India (RBI) typologies for detecting circular layering loops and smurfing transactions (&lt;₹50,000 threshold).</a:t>
             </a:r>
           </a:p>
@@ -7150,7 +7223,7 @@
               </a:spcAft>
             </a:pPr>
             <a:r>
-              <a:rPr sz="1200" b="1">
+              <a:rPr sz="1200" b="1" dirty="0">
                 <a:solidFill>
                   <a:srgbClr val="047857"/>
                 </a:solidFill>
@@ -7159,13 +7232,31 @@
               <a:t>⚡ Working Prototype Status: </a:t>
             </a:r>
             <a:r>
-              <a:rPr sz="1150">
+              <a:rPr sz="1150" dirty="0">
                 <a:solidFill>
                   <a:srgbClr val="1E293B"/>
                 </a:solidFill>
                 <a:latin typeface="Segoe UI"/>
               </a:rPr>
-              <a:t>Live full-stack FastAPI + React 19 platform pre-loaded with 372 suspect nodes and 869 evidence links. Ready for live demonstration.</a:t>
+              <a:t>Live full-stack </a:t>
+            </a:r>
+            <a:r>
+              <a:rPr sz="1150" dirty="0" err="1">
+                <a:solidFill>
+                  <a:srgbClr val="1E293B"/>
+                </a:solidFill>
+                <a:latin typeface="Segoe UI"/>
+              </a:rPr>
+              <a:t>FastAPI</a:t>
+            </a:r>
+            <a:r>
+              <a:rPr sz="1150" dirty="0">
+                <a:solidFill>
+                  <a:srgbClr val="1E293B"/>
+                </a:solidFill>
+                <a:latin typeface="Segoe UI"/>
+              </a:rPr>
+              <a:t> + React 19 platform pre-loaded with 372 suspect nodes and 869 evidence links. Ready for live demonstration.</a:t>
             </a:r>
           </a:p>
           <a:p>
@@ -7178,6 +7269,7 @@
               </a:defRPr>
             </a:pPr>
             <a:r>
+              <a:rPr dirty="0"/>
               <a:t>THANK YOU • Team Stryker • Problem Statement ID: 26189 • Open for Live Demonstration &amp; Q&amp;A</a:t>
             </a:r>
           </a:p>

</xml_diff>